<commit_message>
Añadir proyecto FidelityChain (Módulo 6) y documentación completa
- 6 documentos en docs/modulo-6/:
  01 diseño funcional, 02 arquitectura red, 03 chaincode,
  04 despliegue, 05 app cliente, 06 pruebas y demo
- Código fuente en proyecto-fidelitychain/:
  network (crypto-config, configtx, docker-compose),
  scripts (start, deploy, stop, clean),
  application (package.json)
- Diagramas Mermaid en todos los documentos
- Guión de demo y checklist de evaluación

Co-Authored-By: Claude Opus 4.6 (1M context) <noreply@anthropic.com>
</commit_message>
<xml_diff>
--- a/docs/slides/Modulo 4/dia_2.pptx
+++ b/docs/slides/Modulo 4/dia_2.pptx
@@ -325,7 +325,7 @@
           <a:p>
             <a:fld id="{5BCAD085-E8A6-8845-BD4E-CB4CCA059FC4}" type="datetimeFigureOut">
               <a:rPr lang="en-US" smtClean="0"/>
-              <a:t>4/13/2026</a:t>
+              <a:t>4/16/2026</a:t>
             </a:fld>
             <a:endParaRPr lang="en-US"/>
           </a:p>
@@ -493,7 +493,7 @@
           <a:p>
             <a:fld id="{5BCAD085-E8A6-8845-BD4E-CB4CCA059FC4}" type="datetimeFigureOut">
               <a:rPr lang="en-US" smtClean="0"/>
-              <a:t>4/13/2026</a:t>
+              <a:t>4/16/2026</a:t>
             </a:fld>
             <a:endParaRPr lang="en-US"/>
           </a:p>
@@ -671,7 +671,7 @@
           <a:p>
             <a:fld id="{5BCAD085-E8A6-8845-BD4E-CB4CCA059FC4}" type="datetimeFigureOut">
               <a:rPr lang="en-US" smtClean="0"/>
-              <a:t>4/13/2026</a:t>
+              <a:t>4/16/2026</a:t>
             </a:fld>
             <a:endParaRPr lang="en-US"/>
           </a:p>
@@ -839,7 +839,7 @@
           <a:p>
             <a:fld id="{5BCAD085-E8A6-8845-BD4E-CB4CCA059FC4}" type="datetimeFigureOut">
               <a:rPr lang="en-US" smtClean="0"/>
-              <a:t>4/13/2026</a:t>
+              <a:t>4/16/2026</a:t>
             </a:fld>
             <a:endParaRPr lang="en-US"/>
           </a:p>
@@ -1084,7 +1084,7 @@
           <a:p>
             <a:fld id="{5BCAD085-E8A6-8845-BD4E-CB4CCA059FC4}" type="datetimeFigureOut">
               <a:rPr lang="en-US" smtClean="0"/>
-              <a:t>4/13/2026</a:t>
+              <a:t>4/16/2026</a:t>
             </a:fld>
             <a:endParaRPr lang="en-US"/>
           </a:p>
@@ -1369,7 +1369,7 @@
           <a:p>
             <a:fld id="{5BCAD085-E8A6-8845-BD4E-CB4CCA059FC4}" type="datetimeFigureOut">
               <a:rPr lang="en-US" smtClean="0"/>
-              <a:t>4/13/2026</a:t>
+              <a:t>4/16/2026</a:t>
             </a:fld>
             <a:endParaRPr lang="en-US"/>
           </a:p>
@@ -1788,7 +1788,7 @@
           <a:p>
             <a:fld id="{5BCAD085-E8A6-8845-BD4E-CB4CCA059FC4}" type="datetimeFigureOut">
               <a:rPr lang="en-US" smtClean="0"/>
-              <a:t>4/13/2026</a:t>
+              <a:t>4/16/2026</a:t>
             </a:fld>
             <a:endParaRPr lang="en-US"/>
           </a:p>
@@ -1905,7 +1905,7 @@
           <a:p>
             <a:fld id="{5BCAD085-E8A6-8845-BD4E-CB4CCA059FC4}" type="datetimeFigureOut">
               <a:rPr lang="en-US" smtClean="0"/>
-              <a:t>4/13/2026</a:t>
+              <a:t>4/16/2026</a:t>
             </a:fld>
             <a:endParaRPr lang="en-US"/>
           </a:p>
@@ -2000,7 +2000,7 @@
           <a:p>
             <a:fld id="{5BCAD085-E8A6-8845-BD4E-CB4CCA059FC4}" type="datetimeFigureOut">
               <a:rPr lang="en-US" smtClean="0"/>
-              <a:t>4/13/2026</a:t>
+              <a:t>4/16/2026</a:t>
             </a:fld>
             <a:endParaRPr lang="en-US"/>
           </a:p>
@@ -2275,7 +2275,7 @@
           <a:p>
             <a:fld id="{5BCAD085-E8A6-8845-BD4E-CB4CCA059FC4}" type="datetimeFigureOut">
               <a:rPr lang="en-US" smtClean="0"/>
-              <a:t>4/13/2026</a:t>
+              <a:t>4/16/2026</a:t>
             </a:fld>
             <a:endParaRPr lang="en-US"/>
           </a:p>
@@ -2527,7 +2527,7 @@
           <a:p>
             <a:fld id="{5BCAD085-E8A6-8845-BD4E-CB4CCA059FC4}" type="datetimeFigureOut">
               <a:rPr lang="en-US" smtClean="0"/>
-              <a:t>4/13/2026</a:t>
+              <a:t>4/16/2026</a:t>
             </a:fld>
             <a:endParaRPr lang="en-US"/>
           </a:p>
@@ -2738,7 +2738,7 @@
           <a:p>
             <a:fld id="{5BCAD085-E8A6-8845-BD4E-CB4CCA059FC4}" type="datetimeFigureOut">
               <a:rPr lang="en-US" smtClean="0"/>
-              <a:t>4/13/2026</a:t>
+              <a:t>4/16/2026</a:t>
             </a:fld>
             <a:endParaRPr lang="en-US"/>
           </a:p>
@@ -7501,94 +7501,916 @@
           <a:bodyPr wrap="square"/>
           <a:lstStyle/>
           <a:p>
-            <a:br/>
-            <a:r>
-              <a:t>// Delete: borrado logico (cambiar status) vs fisico (DelState)</a:t>
-            </a:r>
-            <a:br/>
-            <a:r>
-              <a:t>func (s *SmartContract) DeactivateProperty(ctx contractapi.TransactionContextInterface,</a:t>
-            </a:r>
-            <a:br/>
-            <a:r>
+            <a:br>
+              <a:rPr sz="1200" dirty="0">
+                <a:solidFill>
+                  <a:schemeClr val="bg1"/>
+                </a:solidFill>
+              </a:rPr>
+            </a:br>
+            <a:r>
+              <a:rPr sz="1200" dirty="0">
+                <a:solidFill>
+                  <a:schemeClr val="bg1"/>
+                </a:solidFill>
+              </a:rPr>
+              <a:t>// Delete: </a:t>
+            </a:r>
+            <a:r>
+              <a:rPr sz="1200" dirty="0" err="1">
+                <a:solidFill>
+                  <a:schemeClr val="bg1"/>
+                </a:solidFill>
+              </a:rPr>
+              <a:t>borrado</a:t>
+            </a:r>
+            <a:r>
+              <a:rPr sz="1200" dirty="0">
+                <a:solidFill>
+                  <a:schemeClr val="bg1"/>
+                </a:solidFill>
+              </a:rPr>
+              <a:t> </a:t>
+            </a:r>
+            <a:r>
+              <a:rPr sz="1200" dirty="0" err="1">
+                <a:solidFill>
+                  <a:schemeClr val="bg1"/>
+                </a:solidFill>
+              </a:rPr>
+              <a:t>logico</a:t>
+            </a:r>
+            <a:r>
+              <a:rPr sz="1200" dirty="0">
+                <a:solidFill>
+                  <a:schemeClr val="bg1"/>
+                </a:solidFill>
+              </a:rPr>
+              <a:t> (</a:t>
+            </a:r>
+            <a:r>
+              <a:rPr sz="1200" dirty="0" err="1">
+                <a:solidFill>
+                  <a:schemeClr val="bg1"/>
+                </a:solidFill>
+              </a:rPr>
+              <a:t>cambiar</a:t>
+            </a:r>
+            <a:r>
+              <a:rPr sz="1200" dirty="0">
+                <a:solidFill>
+                  <a:schemeClr val="bg1"/>
+                </a:solidFill>
+              </a:rPr>
+              <a:t> status) vs </a:t>
+            </a:r>
+            <a:r>
+              <a:rPr sz="1200" dirty="0" err="1">
+                <a:solidFill>
+                  <a:schemeClr val="bg1"/>
+                </a:solidFill>
+              </a:rPr>
+              <a:t>fisico</a:t>
+            </a:r>
+            <a:r>
+              <a:rPr sz="1200" dirty="0">
+                <a:solidFill>
+                  <a:schemeClr val="bg1"/>
+                </a:solidFill>
+              </a:rPr>
+              <a:t> (</a:t>
+            </a:r>
+            <a:r>
+              <a:rPr sz="1200" dirty="0" err="1">
+                <a:solidFill>
+                  <a:schemeClr val="bg1"/>
+                </a:solidFill>
+              </a:rPr>
+              <a:t>DelState</a:t>
+            </a:r>
+            <a:r>
+              <a:rPr sz="1200" dirty="0">
+                <a:solidFill>
+                  <a:schemeClr val="bg1"/>
+                </a:solidFill>
+              </a:rPr>
+              <a:t>)</a:t>
+            </a:r>
+            <a:br>
+              <a:rPr sz="1200" dirty="0">
+                <a:solidFill>
+                  <a:schemeClr val="bg1"/>
+                </a:solidFill>
+              </a:rPr>
+            </a:br>
+            <a:r>
+              <a:rPr sz="1200" dirty="0" err="1">
+                <a:solidFill>
+                  <a:schemeClr val="bg1"/>
+                </a:solidFill>
+              </a:rPr>
+              <a:t>func</a:t>
+            </a:r>
+            <a:r>
+              <a:rPr sz="1200" dirty="0">
+                <a:solidFill>
+                  <a:schemeClr val="bg1"/>
+                </a:solidFill>
+              </a:rPr>
+              <a:t> (s *</a:t>
+            </a:r>
+            <a:r>
+              <a:rPr sz="1200" dirty="0" err="1">
+                <a:solidFill>
+                  <a:schemeClr val="bg1"/>
+                </a:solidFill>
+              </a:rPr>
+              <a:t>SmartContract</a:t>
+            </a:r>
+            <a:r>
+              <a:rPr sz="1200" dirty="0">
+                <a:solidFill>
+                  <a:schemeClr val="bg1"/>
+                </a:solidFill>
+              </a:rPr>
+              <a:t>) </a:t>
+            </a:r>
+            <a:r>
+              <a:rPr sz="1200" dirty="0" err="1">
+                <a:solidFill>
+                  <a:schemeClr val="bg1"/>
+                </a:solidFill>
+              </a:rPr>
+              <a:t>DeactivateProperty</a:t>
+            </a:r>
+            <a:r>
+              <a:rPr sz="1200" dirty="0">
+                <a:solidFill>
+                  <a:schemeClr val="bg1"/>
+                </a:solidFill>
+              </a:rPr>
+              <a:t>(</a:t>
+            </a:r>
+            <a:r>
+              <a:rPr sz="1200" dirty="0" err="1">
+                <a:solidFill>
+                  <a:schemeClr val="bg1"/>
+                </a:solidFill>
+              </a:rPr>
+              <a:t>ctx</a:t>
+            </a:r>
+            <a:r>
+              <a:rPr sz="1200" dirty="0">
+                <a:solidFill>
+                  <a:schemeClr val="bg1"/>
+                </a:solidFill>
+              </a:rPr>
+              <a:t> </a:t>
+            </a:r>
+            <a:r>
+              <a:rPr sz="1200" dirty="0" err="1">
+                <a:solidFill>
+                  <a:schemeClr val="bg1"/>
+                </a:solidFill>
+              </a:rPr>
+              <a:t>contractapi.TransactionContextInterface</a:t>
+            </a:r>
+            <a:r>
+              <a:rPr sz="1200" dirty="0">
+                <a:solidFill>
+                  <a:schemeClr val="bg1"/>
+                </a:solidFill>
+              </a:rPr>
+              <a:t>,</a:t>
+            </a:r>
+            <a:br>
+              <a:rPr sz="1200" dirty="0">
+                <a:solidFill>
+                  <a:schemeClr val="bg1"/>
+                </a:solidFill>
+              </a:rPr>
+            </a:br>
+            <a:r>
+              <a:rPr sz="1200" dirty="0">
+                <a:solidFill>
+                  <a:schemeClr val="bg1"/>
+                </a:solidFill>
+              </a:rPr>
               <a:t>    id string) error {</a:t>
             </a:r>
-            <a:br/>
-            <a:r>
-              <a:t>    property, err := s.ReadProperty(ctx, id)</a:t>
-            </a:r>
-            <a:br/>
-            <a:r>
+            <a:br>
+              <a:rPr sz="1200" dirty="0">
+                <a:solidFill>
+                  <a:schemeClr val="bg1"/>
+                </a:solidFill>
+              </a:rPr>
+            </a:br>
+            <a:r>
+              <a:rPr sz="1200" dirty="0">
+                <a:solidFill>
+                  <a:schemeClr val="bg1"/>
+                </a:solidFill>
+              </a:rPr>
+              <a:t>    property, err := </a:t>
+            </a:r>
+            <a:r>
+              <a:rPr sz="1200" dirty="0" err="1">
+                <a:solidFill>
+                  <a:schemeClr val="bg1"/>
+                </a:solidFill>
+              </a:rPr>
+              <a:t>s.ReadProperty</a:t>
+            </a:r>
+            <a:r>
+              <a:rPr sz="1200" dirty="0">
+                <a:solidFill>
+                  <a:schemeClr val="bg1"/>
+                </a:solidFill>
+              </a:rPr>
+              <a:t>(</a:t>
+            </a:r>
+            <a:r>
+              <a:rPr sz="1200" dirty="0" err="1">
+                <a:solidFill>
+                  <a:schemeClr val="bg1"/>
+                </a:solidFill>
+              </a:rPr>
+              <a:t>ctx</a:t>
+            </a:r>
+            <a:r>
+              <a:rPr sz="1200" dirty="0">
+                <a:solidFill>
+                  <a:schemeClr val="bg1"/>
+                </a:solidFill>
+              </a:rPr>
+              <a:t>, id)</a:t>
+            </a:r>
+            <a:br>
+              <a:rPr sz="1200" dirty="0">
+                <a:solidFill>
+                  <a:schemeClr val="bg1"/>
+                </a:solidFill>
+              </a:rPr>
+            </a:br>
+            <a:r>
+              <a:rPr sz="1200" dirty="0">
+                <a:solidFill>
+                  <a:schemeClr val="bg1"/>
+                </a:solidFill>
+              </a:rPr>
               <a:t>    if err != nil {</a:t>
             </a:r>
-            <a:br/>
-            <a:r>
+            <a:br>
+              <a:rPr sz="1200" dirty="0">
+                <a:solidFill>
+                  <a:schemeClr val="bg1"/>
+                </a:solidFill>
+              </a:rPr>
+            </a:br>
+            <a:r>
+              <a:rPr sz="1200" dirty="0">
+                <a:solidFill>
+                  <a:schemeClr val="bg1"/>
+                </a:solidFill>
+              </a:rPr>
               <a:t>        return err</a:t>
             </a:r>
-            <a:br/>
-            <a:r>
+            <a:br>
+              <a:rPr sz="1200" dirty="0">
+                <a:solidFill>
+                  <a:schemeClr val="bg1"/>
+                </a:solidFill>
+              </a:rPr>
+            </a:br>
+            <a:r>
+              <a:rPr sz="1200" dirty="0">
+                <a:solidFill>
+                  <a:schemeClr val="bg1"/>
+                </a:solidFill>
+              </a:rPr>
               <a:t>    }</a:t>
             </a:r>
-            <a:br/>
-            <a:r>
-              <a:t>    property.Status = "inactive"  // borrado logico: mantiene historial</a:t>
-            </a:r>
-            <a:br/>
-            <a:r>
-              <a:t>    propertyJSON, _ := json.Marshal(property)</a:t>
-            </a:r>
-            <a:br/>
-            <a:r>
-              <a:t>    return ctx.GetStub().PutState(id, propertyJSON)</a:t>
-            </a:r>
-            <a:br/>
-            <a:r>
+            <a:br>
+              <a:rPr sz="1200" dirty="0">
+                <a:solidFill>
+                  <a:schemeClr val="bg1"/>
+                </a:solidFill>
+              </a:rPr>
+            </a:br>
+            <a:r>
+              <a:rPr sz="1200" dirty="0">
+                <a:solidFill>
+                  <a:schemeClr val="bg1"/>
+                </a:solidFill>
+              </a:rPr>
+              <a:t>    </a:t>
+            </a:r>
+            <a:r>
+              <a:rPr sz="1200" dirty="0" err="1">
+                <a:solidFill>
+                  <a:schemeClr val="bg1"/>
+                </a:solidFill>
+              </a:rPr>
+              <a:t>property.Status</a:t>
+            </a:r>
+            <a:r>
+              <a:rPr sz="1200" dirty="0">
+                <a:solidFill>
+                  <a:schemeClr val="bg1"/>
+                </a:solidFill>
+              </a:rPr>
+              <a:t> = "inactive"  // </a:t>
+            </a:r>
+            <a:r>
+              <a:rPr sz="1200" dirty="0" err="1">
+                <a:solidFill>
+                  <a:schemeClr val="bg1"/>
+                </a:solidFill>
+              </a:rPr>
+              <a:t>borrado</a:t>
+            </a:r>
+            <a:r>
+              <a:rPr sz="1200" dirty="0">
+                <a:solidFill>
+                  <a:schemeClr val="bg1"/>
+                </a:solidFill>
+              </a:rPr>
+              <a:t> </a:t>
+            </a:r>
+            <a:r>
+              <a:rPr sz="1200" dirty="0" err="1">
+                <a:solidFill>
+                  <a:schemeClr val="bg1"/>
+                </a:solidFill>
+              </a:rPr>
+              <a:t>logico</a:t>
+            </a:r>
+            <a:r>
+              <a:rPr sz="1200" dirty="0">
+                <a:solidFill>
+                  <a:schemeClr val="bg1"/>
+                </a:solidFill>
+              </a:rPr>
+              <a:t>: </a:t>
+            </a:r>
+            <a:r>
+              <a:rPr sz="1200" dirty="0" err="1">
+                <a:solidFill>
+                  <a:schemeClr val="bg1"/>
+                </a:solidFill>
+              </a:rPr>
+              <a:t>mantiene</a:t>
+            </a:r>
+            <a:r>
+              <a:rPr sz="1200" dirty="0">
+                <a:solidFill>
+                  <a:schemeClr val="bg1"/>
+                </a:solidFill>
+              </a:rPr>
+              <a:t> </a:t>
+            </a:r>
+            <a:r>
+              <a:rPr sz="1200" dirty="0" err="1">
+                <a:solidFill>
+                  <a:schemeClr val="bg1"/>
+                </a:solidFill>
+              </a:rPr>
+              <a:t>historial</a:t>
+            </a:r>
+            <a:br>
+              <a:rPr sz="1200" dirty="0">
+                <a:solidFill>
+                  <a:schemeClr val="bg1"/>
+                </a:solidFill>
+              </a:rPr>
+            </a:br>
+            <a:r>
+              <a:rPr sz="1200" dirty="0">
+                <a:solidFill>
+                  <a:schemeClr val="bg1"/>
+                </a:solidFill>
+              </a:rPr>
+              <a:t>    </a:t>
+            </a:r>
+            <a:r>
+              <a:rPr sz="1200" dirty="0" err="1">
+                <a:solidFill>
+                  <a:schemeClr val="bg1"/>
+                </a:solidFill>
+              </a:rPr>
+              <a:t>propertyJSON</a:t>
+            </a:r>
+            <a:r>
+              <a:rPr sz="1200" dirty="0">
+                <a:solidFill>
+                  <a:schemeClr val="bg1"/>
+                </a:solidFill>
+              </a:rPr>
+              <a:t>, _ := </a:t>
+            </a:r>
+            <a:r>
+              <a:rPr sz="1200" dirty="0" err="1">
+                <a:solidFill>
+                  <a:schemeClr val="bg1"/>
+                </a:solidFill>
+              </a:rPr>
+              <a:t>json.Marshal</a:t>
+            </a:r>
+            <a:r>
+              <a:rPr sz="1200" dirty="0">
+                <a:solidFill>
+                  <a:schemeClr val="bg1"/>
+                </a:solidFill>
+              </a:rPr>
+              <a:t>(property)</a:t>
+            </a:r>
+            <a:br>
+              <a:rPr sz="1200" dirty="0">
+                <a:solidFill>
+                  <a:schemeClr val="bg1"/>
+                </a:solidFill>
+              </a:rPr>
+            </a:br>
+            <a:r>
+              <a:rPr sz="1200" dirty="0">
+                <a:solidFill>
+                  <a:schemeClr val="bg1"/>
+                </a:solidFill>
+              </a:rPr>
+              <a:t>    return </a:t>
+            </a:r>
+            <a:r>
+              <a:rPr sz="1200" dirty="0" err="1">
+                <a:solidFill>
+                  <a:schemeClr val="bg1"/>
+                </a:solidFill>
+              </a:rPr>
+              <a:t>ctx.GetStub</a:t>
+            </a:r>
+            <a:r>
+              <a:rPr sz="1200" dirty="0">
+                <a:solidFill>
+                  <a:schemeClr val="bg1"/>
+                </a:solidFill>
+              </a:rPr>
+              <a:t>().</a:t>
+            </a:r>
+            <a:r>
+              <a:rPr sz="1200" dirty="0" err="1">
+                <a:solidFill>
+                  <a:schemeClr val="bg1"/>
+                </a:solidFill>
+              </a:rPr>
+              <a:t>PutState</a:t>
+            </a:r>
+            <a:r>
+              <a:rPr sz="1200" dirty="0">
+                <a:solidFill>
+                  <a:schemeClr val="bg1"/>
+                </a:solidFill>
+              </a:rPr>
+              <a:t>(id, </a:t>
+            </a:r>
+            <a:r>
+              <a:rPr sz="1200" dirty="0" err="1">
+                <a:solidFill>
+                  <a:schemeClr val="bg1"/>
+                </a:solidFill>
+              </a:rPr>
+              <a:t>propertyJSON</a:t>
+            </a:r>
+            <a:r>
+              <a:rPr sz="1200" dirty="0">
+                <a:solidFill>
+                  <a:schemeClr val="bg1"/>
+                </a:solidFill>
+              </a:rPr>
+              <a:t>)</a:t>
+            </a:r>
+            <a:br>
+              <a:rPr sz="1200" dirty="0">
+                <a:solidFill>
+                  <a:schemeClr val="bg1"/>
+                </a:solidFill>
+              </a:rPr>
+            </a:br>
+            <a:r>
+              <a:rPr sz="1200" dirty="0">
+                <a:solidFill>
+                  <a:schemeClr val="bg1"/>
+                </a:solidFill>
+              </a:rPr>
               <a:t>}</a:t>
             </a:r>
-            <a:br/>
-            <a:br/>
-            <a:r>
-              <a:t>// GetAll con paginacion</a:t>
-            </a:r>
-            <a:br/>
-            <a:r>
-              <a:t>func (s *SmartContract) GetAllProperties(ctx contractapi.TransactionContextInterface,</a:t>
-            </a:r>
-            <a:br/>
-            <a:r>
-              <a:t>    pageSize int32, bookmark string) (*PaginatedResult, error) {</a:t>
-            </a:r>
-            <a:br/>
-            <a:br/>
-            <a:r>
-              <a:t>    iterator, metadata, err := ctx.GetStub().</a:t>
-            </a:r>
-            <a:br/>
-            <a:r>
-              <a:t>        GetStateByRangeWithPagination("", "", pageSize, bookmark)</a:t>
-            </a:r>
-            <a:br/>
-            <a:r>
+            <a:br>
+              <a:rPr sz="1200" dirty="0">
+                <a:solidFill>
+                  <a:schemeClr val="bg1"/>
+                </a:solidFill>
+              </a:rPr>
+            </a:br>
+            <a:br>
+              <a:rPr sz="1200" dirty="0">
+                <a:solidFill>
+                  <a:schemeClr val="bg1"/>
+                </a:solidFill>
+              </a:rPr>
+            </a:br>
+            <a:r>
+              <a:rPr sz="1200" dirty="0">
+                <a:solidFill>
+                  <a:schemeClr val="bg1"/>
+                </a:solidFill>
+              </a:rPr>
+              <a:t>// </a:t>
+            </a:r>
+            <a:r>
+              <a:rPr sz="1200" dirty="0" err="1">
+                <a:solidFill>
+                  <a:schemeClr val="bg1"/>
+                </a:solidFill>
+              </a:rPr>
+              <a:t>GetAll</a:t>
+            </a:r>
+            <a:r>
+              <a:rPr sz="1200" dirty="0">
+                <a:solidFill>
+                  <a:schemeClr val="bg1"/>
+                </a:solidFill>
+              </a:rPr>
+              <a:t> con </a:t>
+            </a:r>
+            <a:r>
+              <a:rPr sz="1200" dirty="0" err="1">
+                <a:solidFill>
+                  <a:schemeClr val="bg1"/>
+                </a:solidFill>
+              </a:rPr>
+              <a:t>paginacion</a:t>
+            </a:r>
+            <a:br>
+              <a:rPr sz="1200" dirty="0">
+                <a:solidFill>
+                  <a:schemeClr val="bg1"/>
+                </a:solidFill>
+              </a:rPr>
+            </a:br>
+            <a:r>
+              <a:rPr sz="1200" dirty="0" err="1">
+                <a:solidFill>
+                  <a:schemeClr val="bg1"/>
+                </a:solidFill>
+              </a:rPr>
+              <a:t>func</a:t>
+            </a:r>
+            <a:r>
+              <a:rPr sz="1200" dirty="0">
+                <a:solidFill>
+                  <a:schemeClr val="bg1"/>
+                </a:solidFill>
+              </a:rPr>
+              <a:t> (s *</a:t>
+            </a:r>
+            <a:r>
+              <a:rPr sz="1200" dirty="0" err="1">
+                <a:solidFill>
+                  <a:schemeClr val="bg1"/>
+                </a:solidFill>
+              </a:rPr>
+              <a:t>SmartContract</a:t>
+            </a:r>
+            <a:r>
+              <a:rPr sz="1200" dirty="0">
+                <a:solidFill>
+                  <a:schemeClr val="bg1"/>
+                </a:solidFill>
+              </a:rPr>
+              <a:t>) </a:t>
+            </a:r>
+            <a:r>
+              <a:rPr sz="1200" dirty="0" err="1">
+                <a:solidFill>
+                  <a:schemeClr val="bg1"/>
+                </a:solidFill>
+              </a:rPr>
+              <a:t>GetAllProperties</a:t>
+            </a:r>
+            <a:r>
+              <a:rPr sz="1200" dirty="0">
+                <a:solidFill>
+                  <a:schemeClr val="bg1"/>
+                </a:solidFill>
+              </a:rPr>
+              <a:t>(</a:t>
+            </a:r>
+            <a:r>
+              <a:rPr sz="1200" dirty="0" err="1">
+                <a:solidFill>
+                  <a:schemeClr val="bg1"/>
+                </a:solidFill>
+              </a:rPr>
+              <a:t>ctx</a:t>
+            </a:r>
+            <a:r>
+              <a:rPr sz="1200" dirty="0">
+                <a:solidFill>
+                  <a:schemeClr val="bg1"/>
+                </a:solidFill>
+              </a:rPr>
+              <a:t> </a:t>
+            </a:r>
+            <a:r>
+              <a:rPr sz="1200" dirty="0" err="1">
+                <a:solidFill>
+                  <a:schemeClr val="bg1"/>
+                </a:solidFill>
+              </a:rPr>
+              <a:t>contractapi.TransactionContextInterface</a:t>
+            </a:r>
+            <a:r>
+              <a:rPr sz="1200" dirty="0">
+                <a:solidFill>
+                  <a:schemeClr val="bg1"/>
+                </a:solidFill>
+              </a:rPr>
+              <a:t>,</a:t>
+            </a:r>
+            <a:br>
+              <a:rPr sz="1200" dirty="0">
+                <a:solidFill>
+                  <a:schemeClr val="bg1"/>
+                </a:solidFill>
+              </a:rPr>
+            </a:br>
+            <a:r>
+              <a:rPr sz="1200" dirty="0">
+                <a:solidFill>
+                  <a:schemeClr val="bg1"/>
+                </a:solidFill>
+              </a:rPr>
+              <a:t>    </a:t>
+            </a:r>
+            <a:r>
+              <a:rPr sz="1200" dirty="0" err="1">
+                <a:solidFill>
+                  <a:schemeClr val="bg1"/>
+                </a:solidFill>
+              </a:rPr>
+              <a:t>pageSize</a:t>
+            </a:r>
+            <a:r>
+              <a:rPr sz="1200" dirty="0">
+                <a:solidFill>
+                  <a:schemeClr val="bg1"/>
+                </a:solidFill>
+              </a:rPr>
+              <a:t> int32, bookmark string) (*</a:t>
+            </a:r>
+            <a:r>
+              <a:rPr sz="1200" dirty="0" err="1">
+                <a:solidFill>
+                  <a:schemeClr val="bg1"/>
+                </a:solidFill>
+              </a:rPr>
+              <a:t>PaginatedResult</a:t>
+            </a:r>
+            <a:r>
+              <a:rPr sz="1200" dirty="0">
+                <a:solidFill>
+                  <a:schemeClr val="bg1"/>
+                </a:solidFill>
+              </a:rPr>
+              <a:t>, error) {</a:t>
+            </a:r>
+            <a:br>
+              <a:rPr sz="1200" dirty="0">
+                <a:solidFill>
+                  <a:schemeClr val="bg1"/>
+                </a:solidFill>
+              </a:rPr>
+            </a:br>
+            <a:br>
+              <a:rPr sz="1200" dirty="0">
+                <a:solidFill>
+                  <a:schemeClr val="bg1"/>
+                </a:solidFill>
+              </a:rPr>
+            </a:br>
+            <a:r>
+              <a:rPr sz="1200" dirty="0">
+                <a:solidFill>
+                  <a:schemeClr val="bg1"/>
+                </a:solidFill>
+              </a:rPr>
+              <a:t>    iterator, metadata, err := </a:t>
+            </a:r>
+            <a:r>
+              <a:rPr sz="1200" dirty="0" err="1">
+                <a:solidFill>
+                  <a:schemeClr val="bg1"/>
+                </a:solidFill>
+              </a:rPr>
+              <a:t>ctx.GetStub</a:t>
+            </a:r>
+            <a:r>
+              <a:rPr sz="1200" dirty="0">
+                <a:solidFill>
+                  <a:schemeClr val="bg1"/>
+                </a:solidFill>
+              </a:rPr>
+              <a:t>().</a:t>
+            </a:r>
+            <a:br>
+              <a:rPr sz="1200" dirty="0">
+                <a:solidFill>
+                  <a:schemeClr val="bg1"/>
+                </a:solidFill>
+              </a:rPr>
+            </a:br>
+            <a:r>
+              <a:rPr sz="1200" dirty="0">
+                <a:solidFill>
+                  <a:schemeClr val="bg1"/>
+                </a:solidFill>
+              </a:rPr>
+              <a:t>        GetStateByRangeWithPagination("", "", </a:t>
+            </a:r>
+            <a:r>
+              <a:rPr sz="1200" dirty="0" err="1">
+                <a:solidFill>
+                  <a:schemeClr val="bg1"/>
+                </a:solidFill>
+              </a:rPr>
+              <a:t>pageSize</a:t>
+            </a:r>
+            <a:r>
+              <a:rPr sz="1200" dirty="0">
+                <a:solidFill>
+                  <a:schemeClr val="bg1"/>
+                </a:solidFill>
+              </a:rPr>
+              <a:t>, bookmark)</a:t>
+            </a:r>
+            <a:br>
+              <a:rPr sz="1200" dirty="0">
+                <a:solidFill>
+                  <a:schemeClr val="bg1"/>
+                </a:solidFill>
+              </a:rPr>
+            </a:br>
+            <a:r>
+              <a:rPr sz="1200" dirty="0">
+                <a:solidFill>
+                  <a:schemeClr val="bg1"/>
+                </a:solidFill>
+              </a:rPr>
               <a:t>    if err != nil {</a:t>
             </a:r>
-            <a:br/>
-            <a:r>
+            <a:br>
+              <a:rPr sz="1200" dirty="0">
+                <a:solidFill>
+                  <a:schemeClr val="bg1"/>
+                </a:solidFill>
+              </a:rPr>
+            </a:br>
+            <a:r>
+              <a:rPr sz="1200" dirty="0">
+                <a:solidFill>
+                  <a:schemeClr val="bg1"/>
+                </a:solidFill>
+              </a:rPr>
               <a:t>        return nil, err</a:t>
             </a:r>
-            <a:br/>
-            <a:r>
+            <a:br>
+              <a:rPr sz="1200" dirty="0">
+                <a:solidFill>
+                  <a:schemeClr val="bg1"/>
+                </a:solidFill>
+              </a:rPr>
+            </a:br>
+            <a:r>
+              <a:rPr sz="1200" dirty="0">
+                <a:solidFill>
+                  <a:schemeClr val="bg1"/>
+                </a:solidFill>
+              </a:rPr>
               <a:t>    }</a:t>
             </a:r>
-            <a:br/>
-            <a:r>
-              <a:t>    defer iterator.Close()</a:t>
-            </a:r>
-            <a:br/>
-            <a:r>
-              <a:t>    // ... iterar y construir resultado con metadata.Bookmark</a:t>
-            </a:r>
-            <a:br/>
-            <a:r>
+            <a:br>
+              <a:rPr sz="1200" dirty="0">
+                <a:solidFill>
+                  <a:schemeClr val="bg1"/>
+                </a:solidFill>
+              </a:rPr>
+            </a:br>
+            <a:r>
+              <a:rPr sz="1200" dirty="0">
+                <a:solidFill>
+                  <a:schemeClr val="bg1"/>
+                </a:solidFill>
+              </a:rPr>
+              <a:t>    defer </a:t>
+            </a:r>
+            <a:r>
+              <a:rPr sz="1200" dirty="0" err="1">
+                <a:solidFill>
+                  <a:schemeClr val="bg1"/>
+                </a:solidFill>
+              </a:rPr>
+              <a:t>iterator.Close</a:t>
+            </a:r>
+            <a:r>
+              <a:rPr sz="1200" dirty="0">
+                <a:solidFill>
+                  <a:schemeClr val="bg1"/>
+                </a:solidFill>
+              </a:rPr>
+              <a:t>()</a:t>
+            </a:r>
+            <a:br>
+              <a:rPr sz="1200" dirty="0">
+                <a:solidFill>
+                  <a:schemeClr val="bg1"/>
+                </a:solidFill>
+              </a:rPr>
+            </a:br>
+            <a:r>
+              <a:rPr sz="1200" dirty="0">
+                <a:solidFill>
+                  <a:schemeClr val="bg1"/>
+                </a:solidFill>
+              </a:rPr>
+              <a:t>    // ... </a:t>
+            </a:r>
+            <a:r>
+              <a:rPr sz="1200" dirty="0" err="1">
+                <a:solidFill>
+                  <a:schemeClr val="bg1"/>
+                </a:solidFill>
+              </a:rPr>
+              <a:t>iterar</a:t>
+            </a:r>
+            <a:r>
+              <a:rPr sz="1200" dirty="0">
+                <a:solidFill>
+                  <a:schemeClr val="bg1"/>
+                </a:solidFill>
+              </a:rPr>
+              <a:t> y </a:t>
+            </a:r>
+            <a:r>
+              <a:rPr sz="1200" dirty="0" err="1">
+                <a:solidFill>
+                  <a:schemeClr val="bg1"/>
+                </a:solidFill>
+              </a:rPr>
+              <a:t>construir</a:t>
+            </a:r>
+            <a:r>
+              <a:rPr sz="1200" dirty="0">
+                <a:solidFill>
+                  <a:schemeClr val="bg1"/>
+                </a:solidFill>
+              </a:rPr>
+              <a:t> </a:t>
+            </a:r>
+            <a:r>
+              <a:rPr sz="1200" dirty="0" err="1">
+                <a:solidFill>
+                  <a:schemeClr val="bg1"/>
+                </a:solidFill>
+              </a:rPr>
+              <a:t>resultado</a:t>
+            </a:r>
+            <a:r>
+              <a:rPr sz="1200" dirty="0">
+                <a:solidFill>
+                  <a:schemeClr val="bg1"/>
+                </a:solidFill>
+              </a:rPr>
+              <a:t> con </a:t>
+            </a:r>
+            <a:r>
+              <a:rPr sz="1200" dirty="0" err="1">
+                <a:solidFill>
+                  <a:schemeClr val="bg1"/>
+                </a:solidFill>
+              </a:rPr>
+              <a:t>metadata.Bookmark</a:t>
+            </a:r>
+            <a:br>
+              <a:rPr sz="1200" dirty="0">
+                <a:solidFill>
+                  <a:schemeClr val="bg1"/>
+                </a:solidFill>
+              </a:rPr>
+            </a:br>
+            <a:r>
+              <a:rPr sz="1200" dirty="0">
+                <a:solidFill>
+                  <a:schemeClr val="bg1"/>
+                </a:solidFill>
+              </a:rPr>
               <a:t>}</a:t>
             </a:r>
           </a:p>
@@ -7892,69 +8714,419 @@
               </a:defRPr>
             </a:pPr>
             <a:r>
-              <a:t>Genera un chaincode de Hyperledger Fabric en [Go/Node.js]</a:t>
-            </a:r>
-            <a:br/>
-            <a:r>
-              <a:t>para un sistema de Registro de Propiedad con las siguientes</a:t>
-            </a:r>
-            <a:br/>
-            <a:r>
-              <a:t>especificaciones:</a:t>
-            </a:r>
-            <a:br/>
-            <a:br/>
-            <a:r>
-              <a:t>- Struct/modelo: Property con campos id, address, owner,</a:t>
-            </a:r>
-            <a:br/>
-            <a:r>
-              <a:t>  ownerName, area (int), propertyType (apartment|house|land),</a:t>
-            </a:r>
-            <a:br/>
-            <a:r>
-              <a:t>  status (active|transferring|blocked), appraisalValue (int)</a:t>
-            </a:r>
-            <a:br/>
-            <a:r>
-              <a:t>- Incluye campo docType="property" para queries CouchDB</a:t>
-            </a:r>
-            <a:br/>
-            <a:r>
-              <a:t>- Operaciones CRUD: Create, Read, Update, Delete (logico),</a:t>
-            </a:r>
-            <a:br/>
-            <a:r>
-              <a:t>  GetAll con paginacion</a:t>
-            </a:r>
-            <a:br/>
-            <a:r>
-              <a:t>- Validaciones: verificar existencia, permisos por MSPID</a:t>
-            </a:r>
-            <a:br/>
-            <a:r>
-              <a:t>- Rich query: buscar por propertyType y rango de valor</a:t>
-            </a:r>
-            <a:br/>
-            <a:r>
-              <a:t>- Usa la Contract API oficial de Fabric</a:t>
-            </a:r>
-            <a:br/>
-            <a:r>
-              <a:t>- Incluye eventos para Create y Transfer</a:t>
-            </a:r>
-            <a:br/>
-            <a:r>
-              <a:t>- Anade comentarios explicativos en espanol</a:t>
-            </a:r>
-            <a:br/>
-            <a:br/>
-            <a:r>
-              <a:t>Contexto: es para un curso de formacion, debe ser claro</a:t>
-            </a:r>
-            <a:br/>
-            <a:r>
-              <a:t>y didactico. Usa Fabric 2.5.x.</a:t>
+              <a:rPr sz="1200" dirty="0"/>
+              <a:t>Genera un </a:t>
+            </a:r>
+            <a:r>
+              <a:rPr sz="1200" dirty="0" err="1"/>
+              <a:t>chaincode</a:t>
+            </a:r>
+            <a:r>
+              <a:rPr sz="1200" dirty="0"/>
+              <a:t> de Hyperledger Fabric </a:t>
+            </a:r>
+            <a:r>
+              <a:rPr sz="1200" dirty="0" err="1"/>
+              <a:t>en</a:t>
+            </a:r>
+            <a:r>
+              <a:rPr sz="1200" dirty="0"/>
+              <a:t> [Go/Node.js]</a:t>
+            </a:r>
+            <a:br>
+              <a:rPr sz="1200" dirty="0"/>
+            </a:br>
+            <a:r>
+              <a:rPr sz="1200" dirty="0"/>
+              <a:t>para un </a:t>
+            </a:r>
+            <a:r>
+              <a:rPr sz="1200" dirty="0" err="1"/>
+              <a:t>sistema</a:t>
+            </a:r>
+            <a:r>
+              <a:rPr sz="1200" dirty="0"/>
+              <a:t> de Registro de </a:t>
+            </a:r>
+            <a:r>
+              <a:rPr sz="1200" dirty="0" err="1"/>
+              <a:t>Propiedad</a:t>
+            </a:r>
+            <a:r>
+              <a:rPr sz="1200" dirty="0"/>
+              <a:t> con las </a:t>
+            </a:r>
+            <a:r>
+              <a:rPr sz="1200" dirty="0" err="1"/>
+              <a:t>siguientes</a:t>
+            </a:r>
+            <a:br>
+              <a:rPr sz="1200" dirty="0"/>
+            </a:br>
+            <a:r>
+              <a:rPr sz="1200" dirty="0" err="1"/>
+              <a:t>especificaciones</a:t>
+            </a:r>
+            <a:r>
+              <a:rPr sz="1200" dirty="0"/>
+              <a:t>:</a:t>
+            </a:r>
+            <a:br>
+              <a:rPr sz="1200" dirty="0"/>
+            </a:br>
+            <a:br>
+              <a:rPr sz="1200" dirty="0"/>
+            </a:br>
+            <a:r>
+              <a:rPr sz="1200" dirty="0"/>
+              <a:t>- Struct/</a:t>
+            </a:r>
+            <a:r>
+              <a:rPr sz="1200" dirty="0" err="1"/>
+              <a:t>modelo</a:t>
+            </a:r>
+            <a:r>
+              <a:rPr sz="1200" dirty="0"/>
+              <a:t>: Property con campos id, address, owner,</a:t>
+            </a:r>
+            <a:br>
+              <a:rPr sz="1200" dirty="0"/>
+            </a:br>
+            <a:r>
+              <a:rPr sz="1200" dirty="0"/>
+              <a:t>  </a:t>
+            </a:r>
+            <a:r>
+              <a:rPr sz="1200" dirty="0" err="1"/>
+              <a:t>ownerName</a:t>
+            </a:r>
+            <a:r>
+              <a:rPr sz="1200" dirty="0"/>
+              <a:t>, area (int), </a:t>
+            </a:r>
+            <a:r>
+              <a:rPr sz="1200" dirty="0" err="1"/>
+              <a:t>propertyType</a:t>
+            </a:r>
+            <a:r>
+              <a:rPr sz="1200" dirty="0"/>
+              <a:t> (</a:t>
+            </a:r>
+            <a:r>
+              <a:rPr sz="1200" dirty="0" err="1"/>
+              <a:t>apartment|house|land</a:t>
+            </a:r>
+            <a:r>
+              <a:rPr sz="1200" dirty="0"/>
+              <a:t>),</a:t>
+            </a:r>
+            <a:br>
+              <a:rPr sz="1200" dirty="0"/>
+            </a:br>
+            <a:r>
+              <a:rPr sz="1200" dirty="0"/>
+              <a:t>  status (</a:t>
+            </a:r>
+            <a:r>
+              <a:rPr sz="1200" dirty="0" err="1"/>
+              <a:t>active|transferring|blocked</a:t>
+            </a:r>
+            <a:r>
+              <a:rPr sz="1200" dirty="0"/>
+              <a:t>), </a:t>
+            </a:r>
+            <a:r>
+              <a:rPr sz="1200" dirty="0" err="1"/>
+              <a:t>appraisalValue</a:t>
+            </a:r>
+            <a:r>
+              <a:rPr sz="1200" dirty="0"/>
+              <a:t> (int)</a:t>
+            </a:r>
+            <a:br>
+              <a:rPr sz="1200" dirty="0"/>
+            </a:br>
+            <a:r>
+              <a:rPr sz="1200" dirty="0"/>
+              <a:t>- </a:t>
+            </a:r>
+            <a:r>
+              <a:rPr sz="1200" dirty="0" err="1"/>
+              <a:t>Incluye</a:t>
+            </a:r>
+            <a:r>
+              <a:rPr sz="1200" dirty="0"/>
+              <a:t> campo </a:t>
+            </a:r>
+            <a:r>
+              <a:rPr sz="1200" dirty="0" err="1"/>
+              <a:t>docType</a:t>
+            </a:r>
+            <a:r>
+              <a:rPr sz="1200" dirty="0"/>
+              <a:t>="property" para queries CouchDB</a:t>
+            </a:r>
+            <a:br>
+              <a:rPr sz="1200" dirty="0"/>
+            </a:br>
+            <a:r>
+              <a:rPr sz="1200" dirty="0"/>
+              <a:t>- </a:t>
+            </a:r>
+            <a:r>
+              <a:rPr sz="1200" dirty="0" err="1"/>
+              <a:t>Operaciones</a:t>
+            </a:r>
+            <a:r>
+              <a:rPr sz="1200" dirty="0"/>
+              <a:t> CRUD: Create, Read, Update, Delete (</a:t>
+            </a:r>
+            <a:r>
+              <a:rPr sz="1200" dirty="0" err="1"/>
+              <a:t>logico</a:t>
+            </a:r>
+            <a:r>
+              <a:rPr sz="1200" dirty="0"/>
+              <a:t>),</a:t>
+            </a:r>
+            <a:br>
+              <a:rPr sz="1200" dirty="0"/>
+            </a:br>
+            <a:r>
+              <a:rPr sz="1200" dirty="0"/>
+              <a:t>  </a:t>
+            </a:r>
+            <a:r>
+              <a:rPr sz="1200" dirty="0" err="1"/>
+              <a:t>GetAll</a:t>
+            </a:r>
+            <a:r>
+              <a:rPr sz="1200" dirty="0"/>
+              <a:t> con </a:t>
+            </a:r>
+            <a:r>
+              <a:rPr sz="1200" dirty="0" err="1"/>
+              <a:t>paginacion</a:t>
+            </a:r>
+            <a:br>
+              <a:rPr sz="1200" dirty="0"/>
+            </a:br>
+            <a:r>
+              <a:rPr sz="1200" dirty="0"/>
+              <a:t>- </a:t>
+            </a:r>
+            <a:r>
+              <a:rPr sz="1200" dirty="0" err="1"/>
+              <a:t>Validaciones</a:t>
+            </a:r>
+            <a:r>
+              <a:rPr sz="1200" dirty="0"/>
+              <a:t>: </a:t>
+            </a:r>
+            <a:r>
+              <a:rPr sz="1200" dirty="0" err="1"/>
+              <a:t>verificar</a:t>
+            </a:r>
+            <a:r>
+              <a:rPr sz="1200" dirty="0"/>
+              <a:t> </a:t>
+            </a:r>
+            <a:r>
+              <a:rPr sz="1200" dirty="0" err="1"/>
+              <a:t>existencia</a:t>
+            </a:r>
+            <a:r>
+              <a:rPr sz="1200" dirty="0"/>
+              <a:t>, </a:t>
+            </a:r>
+            <a:r>
+              <a:rPr sz="1200" dirty="0" err="1"/>
+              <a:t>permisos</a:t>
+            </a:r>
+            <a:r>
+              <a:rPr sz="1200" dirty="0"/>
+              <a:t> </a:t>
+            </a:r>
+            <a:r>
+              <a:rPr sz="1200" dirty="0" err="1"/>
+              <a:t>por</a:t>
+            </a:r>
+            <a:r>
+              <a:rPr sz="1200" dirty="0"/>
+              <a:t> MSPID</a:t>
+            </a:r>
+            <a:br>
+              <a:rPr sz="1200" dirty="0"/>
+            </a:br>
+            <a:r>
+              <a:rPr sz="1200" dirty="0"/>
+              <a:t>- Rich query: </a:t>
+            </a:r>
+            <a:r>
+              <a:rPr sz="1200" dirty="0" err="1"/>
+              <a:t>buscar</a:t>
+            </a:r>
+            <a:r>
+              <a:rPr sz="1200" dirty="0"/>
+              <a:t> </a:t>
+            </a:r>
+            <a:r>
+              <a:rPr sz="1200" dirty="0" err="1"/>
+              <a:t>por</a:t>
+            </a:r>
+            <a:r>
+              <a:rPr sz="1200" dirty="0"/>
+              <a:t> </a:t>
+            </a:r>
+            <a:r>
+              <a:rPr sz="1200" dirty="0" err="1"/>
+              <a:t>propertyType</a:t>
+            </a:r>
+            <a:r>
+              <a:rPr sz="1200" dirty="0"/>
+              <a:t> y </a:t>
+            </a:r>
+            <a:r>
+              <a:rPr sz="1200" dirty="0" err="1"/>
+              <a:t>rango</a:t>
+            </a:r>
+            <a:r>
+              <a:rPr sz="1200" dirty="0"/>
+              <a:t> de valor</a:t>
+            </a:r>
+            <a:br>
+              <a:rPr sz="1200" dirty="0"/>
+            </a:br>
+            <a:r>
+              <a:rPr sz="1200" dirty="0"/>
+              <a:t>- Usa la Contract API </a:t>
+            </a:r>
+            <a:r>
+              <a:rPr sz="1200" dirty="0" err="1"/>
+              <a:t>oficial</a:t>
+            </a:r>
+            <a:r>
+              <a:rPr sz="1200" dirty="0"/>
+              <a:t> de Fabric</a:t>
+            </a:r>
+            <a:br>
+              <a:rPr sz="1200" dirty="0"/>
+            </a:br>
+            <a:r>
+              <a:rPr sz="1200" dirty="0"/>
+              <a:t>- </a:t>
+            </a:r>
+            <a:r>
+              <a:rPr sz="1200" dirty="0" err="1"/>
+              <a:t>Incluye</a:t>
+            </a:r>
+            <a:r>
+              <a:rPr sz="1200" dirty="0"/>
+              <a:t> </a:t>
+            </a:r>
+            <a:r>
+              <a:rPr sz="1200" dirty="0" err="1"/>
+              <a:t>eventos</a:t>
+            </a:r>
+            <a:r>
+              <a:rPr sz="1200" dirty="0"/>
+              <a:t> para Create y Transfer</a:t>
+            </a:r>
+            <a:br>
+              <a:rPr sz="1200" dirty="0"/>
+            </a:br>
+            <a:r>
+              <a:rPr sz="1200" dirty="0"/>
+              <a:t>- </a:t>
+            </a:r>
+            <a:r>
+              <a:rPr sz="1200" dirty="0" err="1"/>
+              <a:t>Anade</a:t>
+            </a:r>
+            <a:r>
+              <a:rPr sz="1200" dirty="0"/>
+              <a:t> </a:t>
+            </a:r>
+            <a:r>
+              <a:rPr sz="1200" dirty="0" err="1"/>
+              <a:t>comentarios</a:t>
+            </a:r>
+            <a:r>
+              <a:rPr sz="1200" dirty="0"/>
+              <a:t> </a:t>
+            </a:r>
+            <a:r>
+              <a:rPr sz="1200" dirty="0" err="1"/>
+              <a:t>explicativos</a:t>
+            </a:r>
+            <a:r>
+              <a:rPr sz="1200" dirty="0"/>
+              <a:t> </a:t>
+            </a:r>
+            <a:r>
+              <a:rPr sz="1200" dirty="0" err="1"/>
+              <a:t>en</a:t>
+            </a:r>
+            <a:r>
+              <a:rPr sz="1200" dirty="0"/>
+              <a:t> </a:t>
+            </a:r>
+            <a:r>
+              <a:rPr sz="1200" dirty="0" err="1"/>
+              <a:t>espanol</a:t>
+            </a:r>
+            <a:br>
+              <a:rPr sz="1200" dirty="0"/>
+            </a:br>
+            <a:br>
+              <a:rPr sz="1200" dirty="0"/>
+            </a:br>
+            <a:r>
+              <a:rPr sz="1200" dirty="0" err="1"/>
+              <a:t>Contexto</a:t>
+            </a:r>
+            <a:r>
+              <a:rPr sz="1200" dirty="0"/>
+              <a:t>: es para un </a:t>
+            </a:r>
+            <a:r>
+              <a:rPr sz="1200" dirty="0" err="1"/>
+              <a:t>curso</a:t>
+            </a:r>
+            <a:r>
+              <a:rPr sz="1200" dirty="0"/>
+              <a:t> de </a:t>
+            </a:r>
+            <a:r>
+              <a:rPr sz="1200" dirty="0" err="1"/>
+              <a:t>formacion</a:t>
+            </a:r>
+            <a:r>
+              <a:rPr sz="1200" dirty="0"/>
+              <a:t>, </a:t>
+            </a:r>
+            <a:r>
+              <a:rPr sz="1200" dirty="0" err="1"/>
+              <a:t>debe</a:t>
+            </a:r>
+            <a:r>
+              <a:rPr sz="1200" dirty="0"/>
+              <a:t> ser claro</a:t>
+            </a:r>
+            <a:br>
+              <a:rPr sz="1200" dirty="0"/>
+            </a:br>
+            <a:r>
+              <a:rPr sz="1200" dirty="0"/>
+              <a:t>y </a:t>
+            </a:r>
+            <a:r>
+              <a:rPr sz="1200" dirty="0" err="1"/>
+              <a:t>didactico</a:t>
+            </a:r>
+            <a:r>
+              <a:rPr sz="1200" dirty="0"/>
+              <a:t>. Usa Fabric 2.5.x.</a:t>
             </a:r>
           </a:p>
         </p:txBody>

</xml_diff>